<commit_message>
docs: v2 architecture sheets updated with as-built numbers (ADR-008/009)
</commit_message>
<xml_diff>
--- a/docs/diagrams/v2/architecture-v2-drafts.pptx
+++ b/docs/diagrams/v2/architecture-v2-drafts.pptx
@@ -6574,7 +6574,7 @@
                 </a:solidFill>
                 <a:latin typeface="IBM Plex Sans"/>
               </a:rPr>
-              <a:t>* Demo bus: an in-process bus with the same envelope and command catalog. It swaps to Event Hubs and Service Bus without changing messages.</a:t>
+              <a:t>* Demo bus: in-process, same envelope and command catalog (ADR-008). Measured: 7-day nominal seed, 466,662 readings in 7 s (~66k events/s).</a:t>
             </a:r>
           </a:p>
           <a:p>
@@ -6585,7 +6585,7 @@
                 </a:solidFill>
                 <a:latin typeface="IBM Plex Sans"/>
               </a:rPr>
-              <a:t>* Demo stores: metadata in YAML files (same entity model), telemetry and transactions in SQLite, causal chain rebuilt from the event log.</a:t>
+              <a:t>* Demo stores: metadata in YAML loaded at startup (ADR-009); telemetry, event log and transactions in SQLite; 7-day chart read under 1 ms.</a:t>
             </a:r>
           </a:p>
           <a:p>

</xml_diff>